<commit_message>
Slide 4: replace ЭКОНОМИКА block with АНАЛИЗ to avoid duplication with slide 8
Co-authored-by: Даниил <283953798+deraszduz-star@users.noreply.github.com>
</commit_message>
<xml_diff>
--- a/VKR_presentation.pptx
+++ b/VKR_presentation.pptx
@@ -17557,7 +17557,7 @@
                 </a:solidFill>
                 <a:latin typeface="Arial"/>
               </a:rPr>
-              <a:t>•  ДЦ / НДБ / НДЦ</a:t>
+              <a:t>•  5С</a:t>
             </a:r>
           </a:p>
           <a:p>
@@ -17569,7 +17569,7 @@
                 </a:solidFill>
                 <a:latin typeface="Arial"/>
               </a:rPr>
-              <a:t>•  Диаграмма Ишикавы</a:t>
+              <a:t>•  Кайдзен</a:t>
             </a:r>
           </a:p>
           <a:p>
@@ -17581,7 +17581,7 @@
                 </a:solidFill>
                 <a:latin typeface="Arial"/>
               </a:rPr>
-              <a:t>•  5С</a:t>
+              <a:t>•  SMED</a:t>
             </a:r>
           </a:p>
           <a:p>
@@ -17593,7 +17593,7 @@
                 </a:solidFill>
                 <a:latin typeface="Arial"/>
               </a:rPr>
-              <a:t>•  DMAIC</a:t>
+              <a:t>•  Стандартизация</a:t>
             </a:r>
           </a:p>
         </p:txBody>
@@ -17718,7 +17718,7 @@
                 </a:solidFill>
                 <a:latin typeface="Arial"/>
               </a:rPr>
-              <a:t>ЭКОНОМИКА</a:t>
+              <a:t>АНАЛИЗ</a:t>
             </a:r>
           </a:p>
         </p:txBody>
@@ -17753,7 +17753,7 @@
                 </a:solidFill>
                 <a:latin typeface="Arial"/>
               </a:rPr>
-              <a:t>•  NPV</a:t>
+              <a:t>•  SIPOC</a:t>
             </a:r>
           </a:p>
           <a:p>
@@ -17765,7 +17765,7 @@
                 </a:solidFill>
                 <a:latin typeface="Arial"/>
               </a:rPr>
-              <a:t>•  IRR</a:t>
+              <a:t>•  Хронометраж</a:t>
             </a:r>
           </a:p>
           <a:p>
@@ -17777,7 +17777,7 @@
                 </a:solidFill>
                 <a:latin typeface="Arial"/>
               </a:rPr>
-              <a:t>•  DPP</a:t>
+              <a:t>•  ДЦ / НДБ / НДЦ</a:t>
             </a:r>
           </a:p>
           <a:p>
@@ -17789,7 +17789,7 @@
                 </a:solidFill>
                 <a:latin typeface="Arial"/>
               </a:rPr>
-              <a:t>•  Анализ</a:t>
+              <a:t>•  Диаграмма</a:t>
             </a:r>
           </a:p>
           <a:p>
@@ -17801,7 +17801,7 @@
                 </a:solidFill>
                 <a:latin typeface="Arial"/>
               </a:rPr>
-              <a:t>   чувствительности</a:t>
+              <a:t>   Ишикавы</a:t>
             </a:r>
           </a:p>
           <a:p>
@@ -17813,7 +17813,7 @@
                 </a:solidFill>
                 <a:latin typeface="Arial"/>
               </a:rPr>
-              <a:t>•  SMART</a:t>
+              <a:t>•  DMAIC · SMART</a:t>
             </a:r>
           </a:p>
         </p:txBody>
@@ -17892,7 +17892,7 @@
                 </a:solidFill>
                 <a:latin typeface="Arial"/>
               </a:rPr>
-              <a:t>Стек: НОТАЦИИ + LEAN + ИНВЕСТИЦИОННЫЙ АНАЛИЗ — применён к 3 подразделениям КФУ</a:t>
+              <a:t>Стек: ОПИСАНИЕ (нотации) + АНАЛИЗ (узкие места) + УЛУЧШЕНИЕ (Lean) — применён к 3 подразделениям КФУ</a:t>
             </a:r>
           </a:p>
         </p:txBody>

</xml_diff>